<commit_message>
Fix slide 12 text-overflow risk
The new slide's autofit was inherited as "resize shape to fit text" from
its slide-11 template, and the added bullets ran 2-2.6x longer than that
template's own content -- with no way to render the deck here to confirm,
that combination would very likely have grown the text boxes into the
footer below. Shortened the bullets closer to the template's own length and
switched autofit to "shrink text on overflow" so the boxes stay fixed
regardless of exact character count.

Co-Authored-By: Claude Sonnet 5 <noreply@anthropic.com>
</commit_message>
<xml_diff>
--- a/Thesis_Defense_24MSE23204.pptx
+++ b/Thesis_Defense_24MSE23204.pptx
@@ -4942,7 +4942,7 @@
         </p:spPr>
         <p:txBody>
           <a:bodyPr wrap="square" lIns="0" rIns="0" tIns="0" bIns="0">
-            <a:spAutoFit/>
+            <a:normAutofit/>
           </a:bodyPr>
           <a:lstStyle/>
           <a:p>
@@ -4961,7 +4961,7 @@
                 </a:solidFill>
                 <a:latin typeface="Calibri"/>
               </a:rPr>
-              <a:t>•  Naive training (always shipping the last epoch) let a 458-sample medical import measurably worsen recognition: 62.8% WER vs the untrained model’s own 32.0% on the same held-out audio.</a:t>
+              <a:t>•  Naive shipping of the last epoch measurably worsened recognition: 62.8% WER vs base’s own 32.0% on the same held-out audio.</a:t>
             </a:r>
           </a:p>
           <a:p>
@@ -4980,7 +4980,7 @@
                 </a:solidFill>
                 <a:latin typeface="Calibri"/>
               </a:rPr>
-              <a:t>•  First fix (score a held-out split, reject unless it beats the base model) was itself fooled: the same split picked the best epoch and judged accept/reject, so an adapter it accepted as “+9–15pp better” still lost by 20–27pp on a genuinely independent 30-file eval set, twice.</a:t>
+              <a:t>•  The held-out gate was itself fooled: adapters accepted as “9–15pp better” internally still lost 20–27pp on an independent eval set, twice.</a:t>
             </a:r>
           </a:p>
           <a:p>
@@ -4999,7 +4999,7 @@
                 </a:solidFill>
                 <a:latin typeface="Calibri"/>
               </a:rPr>
-              <a:t>•  Root cause: any split carved from one guest’s own upload batch shares that batch’s recording session/speaker/domain characteristics, regardless of split ratio or size (confirmed from 13% to 25% held-out, up to 60 samples).</a:t>
+              <a:t>•  Cause: any split from one guest’s own upload shares that batch’s recording/speaker/domain traits, regardless of split size.</a:t>
             </a:r>
           </a:p>
         </p:txBody>
@@ -5061,7 +5061,7 @@
         </p:spPr>
         <p:txBody>
           <a:bodyPr wrap="square" lIns="0" rIns="0" tIns="0" bIns="0">
-            <a:spAutoFit/>
+            <a:normAutofit/>
           </a:bodyPr>
           <a:lstStyle/>
           <a:p>
@@ -5080,7 +5080,7 @@
                 </a:solidFill>
                 <a:latin typeface="Calibri"/>
               </a:rPr>
-              <a:t>•  Gate 0/Gate 1: split the held-out portion in two — an early-stopping set (never used for accept/reject) and a final-gate set (never used to pick the epoch) — removes the double-dipping bias.</a:t>
+              <a:t>•  Gate 0/1: separate early-stopping and final-gate splits remove the double-dipping bias (one split picking the epoch AND judging accept/reject).</a:t>
             </a:r>
           </a:p>
           <a:p>
@@ -5099,7 +5099,7 @@
                 </a:solidFill>
                 <a:latin typeface="Calibri"/>
               </a:rPr>
-              <a:t>•  Gate 2: score every adapter against a fixed 500-clip general-Vietnamese benchmark (doof-ferb/vlsp2020_vinai_100h) no guest’s upload ever touches — catches regressions Gate 1 structurally cannot see.</a:t>
+              <a:t>•  Gate 2: score every adapter against a fixed 500-clip general-Vietnamese benchmark no guest’s data ever touches.</a:t>
             </a:r>
           </a:p>
           <a:p>
@@ -5118,7 +5118,7 @@
                 </a:solidFill>
                 <a:latin typeface="Calibri"/>
               </a:rPr>
-              <a:t>•  Validated on a real case: a 60-sample medical adapter cleared Gate 1 (52.0% vs 60.2% base on its own domain) but was correctly rejected by Gate 2 (47.6% vs 44.4% base on general Vietnamese).</a:t>
+              <a:t>•  Real case: a 60-sample adapter cleared Gate 1 (52.0% vs 60.2% base) but was rejected by Gate 2 (47.6% vs 44.4% base).</a:t>
             </a:r>
           </a:p>
           <a:p>
@@ -5137,7 +5137,7 @@
                 </a:solidFill>
                 <a:latin typeface="Calibri"/>
               </a:rPr>
-              <a:t>•  Across every configuration tested so far (60–250 samples, LoRA rank 8–16), no Tier 2 adapter has yet beaten the base model on genuinely independent domain data — the three-gate pipeline guarantees none of them ship regardless.</a:t>
+              <a:t>•  No adapter has yet beaten base on independent data — the pipeline still guarantees none ship regardless.</a:t>
             </a:r>
           </a:p>
         </p:txBody>
@@ -5204,7 +5204,7 @@
         </p:spPr>
         <p:txBody>
           <a:bodyPr wrap="square" anchor="t" lIns="0" rIns="0" tIns="0" bIns="0">
-            <a:spAutoFit/>
+            <a:normAutofit/>
           </a:bodyPr>
           <a:lstStyle/>
           <a:p>
@@ -5220,7 +5220,7 @@
                 </a:solidFill>
                 <a:latin typeface="Calibri"/>
               </a:rPr>
-              <a:t>The finding reframes Tier 2’s contribution: not yet a proven quality improvement over base Whisper, but a self-serve fine-tuning pipeline that is provably safe to expose publicly — it never ships a regression, even when the underlying adapter doesn’t help.</a:t>
+              <a:t>Not yet a proven quality improvement over base Whisper — but a self-serve fine-tuning pipeline that is provably safe to expose publicly, since it never ships a regression.</a:t>
             </a:r>
           </a:p>
         </p:txBody>

</xml_diff>